<commit_message>
docs: add D3–D6 mix results, i2i/fuse slides, and demo FN talking point
Record finished mix-in scores so the public repo matches the Devpost write-up, and keep the i2i pixel zip out of git.

Co-authored-by: Cursor <cursoragent@cursor.com>
</commit_message>
<xml_diff>
--- a/docs/slides/TechJam_Challenge5.pptx
+++ b/docs/slides/TechJam_Challenge5.pptx
@@ -655,7 +655,7 @@
           <a:lstStyle/>
           <a:p>
             <a:r>
-              <a:t>EvalGEN 五家都没进训练。GoT/OmniGen 大家接近 1.0，不要当 unseen 代理。Nova 才拉开：last-4 AUC 0.963 召回 0.49，D3 召回 0.86。fuse 保 AUC 0.988，0.5 召回仍只有 0.56，要讲清楚阈值。</a:t>
+              <a:t>EvalGEN 五家都没进训练。GoT/OmniGen 大家接近 1.0，不要当 unseen 代理。Nova 15 档：D3 0.9865，fuse last4+D3 0.9880。last-4 召回 0.49，D3 0.86，fuse 0.56，阈值要讲清楚。</a:t>
             </a:r>
           </a:p>
         </p:txBody>
@@ -725,7 +725,7 @@
           <a:lstStyle/>
           <a:p>
             <a:r>
-              <a:t>画册里 FN 大量是插画、卡通、绘画风 DALL·E，不只是以假乱真的实拍。SID 是社交实拍 FLUX，画风一偏，last-4 分数会过低。另外还有 pred 极低的实拍风 DALL·E，那是排序难题。FP 几乎没有，讲平台误杀贵。</a:t>
+              <a:t>画册里 FN 大量是漫画、插画、卡通、绘画风 DALL·E，不是社交实拍目标。SID 是照片级 FLUX，画风一偏分数会过低。平台场景（实拍社交图）同一阈值下漏检预期会少。但仍有 pred 极低的实拍风 DALL·E，不能说漏检会消失。FP 几乎没有，讲平台误杀贵。</a:t>
             </a:r>
           </a:p>
         </p:txBody>
@@ -1005,7 +1005,7 @@
           <a:lstStyle/>
           <a:p>
             <a:r>
-              <a:t>CIFAKE 官方 0.57，换 SID 社交域加 online aug 到 0.970。D3 补 UNet 和 pixel，Nova 起来。D5 并上 PixArt/GPT 官方还略掉。D6 只加 118 张 i2i fake，官方分几乎不会动，看 pair_acc。</a:t>
+              <a:t>CIFAKE 官方 0.57，换 SID 社交域加 online aug 到 0.970。D3 补 UNet 和 pixel，Nova 起来。D5 并上 PixArt/GPT 官方还略掉。D6 只加 118 张 i2i fake：官方 0.977，pair_acc 0.805，fuse 0.9929，仍提交 last-4 或 last4+D3。</a:t>
             </a:r>
           </a:p>
         </p:txBody>
@@ -1145,7 +1145,7 @@
           <a:lstStyle/>
           <a:p>
             <a:r>
-              <a:t>为什么不训 GAN：官方是 DALL·E，EvalGEN 也不是 GAN；计划里 B 轴可以留作 unseen。时间不够做 10%/20% mix。i2i 必须整图 triplet，不能拿 SID tampered 冒充。A2 官方 0.44，D3 没见过这对数据 pair_acc 反而 0.79。</a:t>
+              <a:t>i2i 必须是整图 triplet。A2 只训 59 组会过拟合，官方 0.44。没有 SID 的 A1/A3 官方最高 0.79。D6 在 D5 上加 118 张 fake，pair_acc 到 0.805，官方仍 0.977，不能换提交。GAN 不进训：官方和 EvalGEN 都不是 StyleGAN。</a:t>
             </a:r>
           </a:p>
         </p:txBody>
@@ -1425,7 +1425,7 @@
           <a:lstStyle/>
           <a:p>
             <a:r>
-              <a:t>解冻后 4 层提升排序，0.5 阈值会更漏。D3 补生成器族。两个目标不能靠一个网络硬叠：last-4 训在 D3 上官方掉到 0.976。推理期平均 logit 保住 DALL·E 又保住 Nova AUC。</a:t>
+              <a:t>两个头互补：last-4 负责官方 DALL·E 排序，D3 补 Nova 召回。不能把 last-4 再训到 mix 上（0.976）。D5/D6 更多 mixin 的 fuse 没有超过 0.993，所以提交仍是 last4+D3。0.5 召回 fuse 只有 0.56，AUC 才是分数。</a:t>
             </a:r>
           </a:p>
         </p:txBody>
@@ -4564,10 +4564,12 @@
           </a:bodyPr>
           <a:lstStyle/>
           <a:p>
-            <a:pPr>
+            <a:pPr marL="256032" indent="-164592">
               <a:spcAft>
                 <a:spcPts val="800"/>
               </a:spcAft>
+              <a:buFont typeface="Arial"/>
+              <a:buChar char="•"/>
             </a:pPr>
             <a:r>
               <a:rPr sz="1600" b="0">
@@ -4580,10 +4582,12 @@
             </a:r>
           </a:p>
           <a:p>
-            <a:pPr>
+            <a:pPr marL="256032" indent="-164592">
               <a:spcAft>
                 <a:spcPts val="800"/>
               </a:spcAft>
+              <a:buFont typeface="Arial"/>
+              <a:buChar char="•"/>
             </a:pPr>
             <a:r>
               <a:rPr sz="1600" b="0">
@@ -5107,10 +5111,12 @@
           </a:bodyPr>
           <a:lstStyle/>
           <a:p>
-            <a:pPr>
+            <a:pPr marL="256032" indent="-164592">
               <a:spcAft>
                 <a:spcPts val="800"/>
               </a:spcAft>
+              <a:buFont typeface="Arial"/>
+              <a:buChar char="•"/>
             </a:pPr>
             <a:r>
               <a:rPr sz="1800" b="0">
@@ -5123,10 +5129,12 @@
             </a:r>
           </a:p>
           <a:p>
-            <a:pPr>
+            <a:pPr marL="256032" indent="-164592">
               <a:spcAft>
                 <a:spcPts val="800"/>
               </a:spcAft>
+              <a:buFont typeface="Arial"/>
+              <a:buChar char="•"/>
             </a:pPr>
             <a:r>
               <a:rPr sz="1800" b="0">
@@ -5139,10 +5147,12 @@
             </a:r>
           </a:p>
           <a:p>
-            <a:pPr>
+            <a:pPr marL="256032" indent="-164592">
               <a:spcAft>
                 <a:spcPts val="800"/>
               </a:spcAft>
+              <a:buFont typeface="Arial"/>
+              <a:buChar char="•"/>
             </a:pPr>
             <a:r>
               <a:rPr sz="1800" b="0">
@@ -5155,10 +5165,12 @@
             </a:r>
           </a:p>
           <a:p>
-            <a:pPr>
+            <a:pPr marL="256032" indent="-164592">
               <a:spcAft>
                 <a:spcPts val="800"/>
               </a:spcAft>
+              <a:buFont typeface="Arial"/>
+              <a:buChar char="•"/>
             </a:pPr>
             <a:r>
               <a:rPr sz="1800" b="0">
@@ -5305,10 +5317,12 @@
           </a:bodyPr>
           <a:lstStyle/>
           <a:p>
-            <a:pPr>
+            <a:pPr marL="256032" indent="-164592">
               <a:spcAft>
                 <a:spcPts val="800"/>
               </a:spcAft>
+              <a:buFont typeface="Arial"/>
+              <a:buChar char="•"/>
             </a:pPr>
             <a:r>
               <a:rPr sz="1800" b="0">
@@ -5321,10 +5335,12 @@
             </a:r>
           </a:p>
           <a:p>
-            <a:pPr>
+            <a:pPr marL="256032" indent="-164592">
               <a:spcAft>
                 <a:spcPts val="800"/>
               </a:spcAft>
+              <a:buFont typeface="Arial"/>
+              <a:buChar char="•"/>
             </a:pPr>
             <a:r>
               <a:rPr sz="1800" b="0">
@@ -5337,10 +5353,12 @@
             </a:r>
           </a:p>
           <a:p>
-            <a:pPr>
+            <a:pPr marL="256032" indent="-164592">
               <a:spcAft>
                 <a:spcPts val="800"/>
               </a:spcAft>
+              <a:buFont typeface="Arial"/>
+              <a:buChar char="•"/>
             </a:pPr>
             <a:r>
               <a:rPr sz="1800" b="0">
@@ -5497,10 +5515,12 @@
           </a:bodyPr>
           <a:lstStyle/>
           <a:p>
-            <a:pPr>
+            <a:pPr marL="256032" indent="-164592">
               <a:spcAft>
                 <a:spcPts val="800"/>
               </a:spcAft>
+              <a:buFont typeface="Arial"/>
+              <a:buChar char="•"/>
             </a:pPr>
             <a:r>
               <a:rPr sz="2000" b="0">
@@ -5513,10 +5533,12 @@
             </a:r>
           </a:p>
           <a:p>
-            <a:pPr>
+            <a:pPr marL="256032" indent="-164592">
               <a:spcAft>
                 <a:spcPts val="800"/>
               </a:spcAft>
+              <a:buFont typeface="Arial"/>
+              <a:buChar char="•"/>
             </a:pPr>
             <a:r>
               <a:rPr sz="2000" b="0">
@@ -5529,10 +5551,12 @@
             </a:r>
           </a:p>
           <a:p>
-            <a:pPr>
+            <a:pPr marL="256032" indent="-164592">
               <a:spcAft>
                 <a:spcPts val="800"/>
               </a:spcAft>
+              <a:buFont typeface="Arial"/>
+              <a:buChar char="•"/>
             </a:pPr>
             <a:r>
               <a:rPr sz="2000" b="0">
@@ -5545,10 +5569,12 @@
             </a:r>
           </a:p>
           <a:p>
-            <a:pPr>
+            <a:pPr marL="256032" indent="-164592">
               <a:spcAft>
                 <a:spcPts val="800"/>
               </a:spcAft>
+              <a:buFont typeface="Arial"/>
+              <a:buChar char="•"/>
             </a:pPr>
             <a:r>
               <a:rPr sz="2000" b="0">
@@ -5729,10 +5755,12 @@
           </a:bodyPr>
           <a:lstStyle/>
           <a:p>
-            <a:pPr>
+            <a:pPr marL="256032" indent="-164592">
               <a:spcAft>
                 <a:spcPts val="800"/>
               </a:spcAft>
+              <a:buFont typeface="Arial"/>
+              <a:buChar char="•"/>
             </a:pPr>
             <a:r>
               <a:rPr sz="1600" b="0">
@@ -5741,14 +5769,16 @@
                 </a:solidFill>
                 <a:latin typeface="Arial"/>
               </a:rPr>
-              <a:t>D3 is the active mix for Nova. D5 = D3 ∪ D4 (new T2I) ≈ D3, not a new jump.</a:t>
-            </a:r>
-          </a:p>
-          <a:p>
-            <a:pPr>
+              <a:t>D3 is the mix that lifts Nova. D5 = D3 ∪ D4 ≈ D3 on official (0.975 vs 0.978), not a jump.</a:t>
+            </a:r>
+          </a:p>
+          <a:p>
+            <a:pPr marL="256032" indent="-164592">
               <a:spcAft>
                 <a:spcPts val="800"/>
               </a:spcAft>
+              <a:buFont typeface="Arial"/>
+              <a:buChar char="•"/>
             </a:pPr>
             <a:r>
               <a:rPr sz="1600" b="0">
@@ -5757,7 +5787,7 @@
                 </a:solidFill>
                 <a:latin typeface="Arial"/>
               </a:rPr>
-              <a:t>D6 = D5 + 118 whole-image i2i fakes (no paired reals). Train still running / pair_acc vs D5.</a:t>
+              <a:t>D6 = D5 + 118 whole-image i2i fakes (no paired reals): official 0.977, pair_acc 0.805. Fuse last4+D6 = 0.9929 vs D3 fuse 0.9930 — do not submit D6.</a:t>
             </a:r>
           </a:p>
         </p:txBody>
@@ -5955,14 +5985,48 @@
                 </a:solidFill>
                 <a:latin typeface="Arial"/>
               </a:rPr>
-              <a:t>Choices: no GAN mix, i2i as paired triplets</a:t>
+              <a:t>i2i: 59 triplets, not 8k  —  SID still required</a:t>
+            </a:r>
+          </a:p>
+        </p:txBody>
+      </p:sp>
+      <p:sp>
+        <p:nvSpPr>
+          <p:cNvPr id="3" name="TextBox 2"/>
+          <p:cNvSpPr txBox="1"/>
+          <p:nvPr/>
+        </p:nvSpPr>
+        <p:spPr>
+          <a:xfrm>
+            <a:off x="411480" y="713232"/>
+            <a:ext cx="11338560" cy="365760"/>
+          </a:xfrm>
+          <a:prstGeom prst="rect">
+            <a:avLst/>
+          </a:prstGeom>
+          <a:noFill/>
+        </p:spPr>
+        <p:txBody>
+          <a:bodyPr wrap="square">
+            <a:spAutoFit/>
+          </a:bodyPr>
+          <a:lstStyle/>
+          <a:p>
+            <a:r>
+              <a:rPr sz="1400" b="0">
+                <a:solidFill>
+                  <a:srgbClr val="64748B"/>
+                </a:solidFill>
+                <a:latin typeface="Arial"/>
+              </a:rPr>
+              <a:t>pair_acc = P(recon_score &gt; paired real) on 118 pairs. A-grid has no SID.</a:t>
             </a:r>
           </a:p>
         </p:txBody>
       </p:sp>
       <p:pic>
         <p:nvPicPr>
-          <p:cNvPr id="3" name="Picture 2" descr="decisions.png"/>
+          <p:cNvPr id="4" name="Picture 3" descr="i2i_table.png"/>
           <p:cNvPicPr>
             <a:picLocks noChangeAspect="1"/>
           </p:cNvPicPr>
@@ -5976,8 +6040,8 @@
         </p:blipFill>
         <p:spPr>
           <a:xfrm>
-            <a:off x="365760" y="1005840"/>
-            <a:ext cx="11430000" cy="4023360"/>
+            <a:off x="365760" y="1024128"/>
+            <a:ext cx="11430000" cy="3246120"/>
           </a:xfrm>
           <a:prstGeom prst="rect">
             <a:avLst/>
@@ -5986,14 +6050,14 @@
       </p:pic>
       <p:sp>
         <p:nvSpPr>
-          <p:cNvPr id="4" name="TextBox 3"/>
+          <p:cNvPr id="5" name="TextBox 4"/>
           <p:cNvSpPr txBox="1"/>
           <p:nvPr/>
         </p:nvSpPr>
         <p:spPr>
           <a:xfrm>
-            <a:off x="457200" y="5166360"/>
-            <a:ext cx="11247120" cy="1280160"/>
+            <a:off x="457200" y="4434840"/>
+            <a:ext cx="11247120" cy="1737360"/>
           </a:xfrm>
           <a:prstGeom prst="rect">
             <a:avLst/>
@@ -6006,42 +6070,64 @@
           </a:bodyPr>
           <a:lstStyle/>
           <a:p>
-            <a:pPr>
+            <a:pPr marL="256032" indent="-164592">
               <a:spcAft>
                 <a:spcPts val="800"/>
               </a:spcAft>
+              <a:buFont typeface="Arial"/>
+              <a:buChar char="•"/>
             </a:pPr>
             <a:r>
-              <a:rPr sz="1600" b="0">
+              <a:rPr sz="1500" b="0">
                 <a:solidFill>
                   <a:srgbClr val="0F172A"/>
                 </a:solidFill>
                 <a:latin typeface="Arial"/>
               </a:rPr>
-              <a:t>GAN left as unseen: contest and EvalGEN are diffusion / flow / AR, not StyleGAN.</a:t>
-            </a:r>
-          </a:p>
-          <a:p>
-            <a:pPr>
+              <a:t>A2 i2i-only official 0.443 / pair 0.42: 59 scenes overfit. Whole-image i2i cannot replace SID.</a:t>
+            </a:r>
+          </a:p>
+          <a:p>
+            <a:pPr marL="256032" indent="-164592">
               <a:spcAft>
                 <a:spcPts val="800"/>
               </a:spcAft>
+              <a:buFont typeface="Arial"/>
+              <a:buChar char="•"/>
             </a:pPr>
             <a:r>
-              <a:rPr sz="1600" b="0">
+              <a:rPr sz="1500" b="0">
                 <a:solidFill>
                   <a:srgbClr val="0F172A"/>
                 </a:solidFill>
                 <a:latin typeface="Arial"/>
               </a:rPr>
-              <a:t>A2 proved 59 i2i scenes overfit. D3 already ranks reconstructions better without seeing them.</a:t>
-            </a:r>
-          </a:p>
-        </p:txBody>
-      </p:sp>
-      <p:sp>
-        <p:nvSpPr>
-          <p:cNvPr id="5" name="TextBox 4"/>
+              <a:t>D6 keeps the SID mix and only adds 118 i2i fakes: pair_acc 0.805, official 0.977. Contest submit stays last-4 / last4+D3.</a:t>
+            </a:r>
+          </a:p>
+          <a:p>
+            <a:pPr marL="256032" indent="-164592">
+              <a:spcAft>
+                <a:spcPts val="800"/>
+              </a:spcAft>
+              <a:buFont typeface="Arial"/>
+              <a:buChar char="•"/>
+            </a:pPr>
+            <a:r>
+              <a:rPr sz="1500" b="0">
+                <a:solidFill>
+                  <a:srgbClr val="0F172A"/>
+                </a:solidFill>
+                <a:latin typeface="Arial"/>
+              </a:rPr>
+              <a:t>SID tampered (label=2) is a local edit, not whole-image i2i. Do not mine DALL·E / EvalGEN into train.</a:t>
+            </a:r>
+          </a:p>
+        </p:txBody>
+      </p:sp>
+      <p:sp>
+        <p:nvSpPr>
+          <p:cNvPr id="6" name="TextBox 5"/>
           <p:cNvSpPr txBox="1"/>
           <p:nvPr/>
         </p:nvSpPr>
@@ -6206,10 +6292,12 @@
           </a:bodyPr>
           <a:lstStyle/>
           <a:p>
-            <a:pPr>
+            <a:pPr marL="256032" indent="-164592">
               <a:spcAft>
                 <a:spcPts val="800"/>
               </a:spcAft>
+              <a:buFont typeface="Arial"/>
+              <a:buChar char="•"/>
             </a:pPr>
             <a:r>
               <a:rPr sz="1600" b="0">
@@ -6222,10 +6310,12 @@
             </a:r>
           </a:p>
           <a:p>
-            <a:pPr>
+            <a:pPr marL="256032" indent="-164592">
               <a:spcAft>
                 <a:spcPts val="800"/>
               </a:spcAft>
+              <a:buFont typeface="Arial"/>
+              <a:buChar char="•"/>
             </a:pPr>
             <a:r>
               <a:rPr sz="1600" b="0">
@@ -6382,10 +6472,12 @@
           </a:bodyPr>
           <a:lstStyle/>
           <a:p>
-            <a:pPr>
+            <a:pPr marL="256032" indent="-164592">
               <a:spcAft>
                 <a:spcPts val="800"/>
               </a:spcAft>
+              <a:buFont typeface="Arial"/>
+              <a:buChar char="•"/>
             </a:pPr>
             <a:r>
               <a:rPr sz="1800" b="0">
@@ -6398,10 +6490,12 @@
             </a:r>
           </a:p>
           <a:p>
-            <a:pPr>
+            <a:pPr marL="256032" indent="-164592">
               <a:spcAft>
                 <a:spcPts val="800"/>
               </a:spcAft>
+              <a:buFont typeface="Arial"/>
+              <a:buChar char="•"/>
             </a:pPr>
             <a:r>
               <a:rPr sz="1800" b="0">
@@ -6414,10 +6508,12 @@
             </a:r>
           </a:p>
           <a:p>
-            <a:pPr>
+            <a:pPr marL="256032" indent="-164592">
               <a:spcAft>
                 <a:spcPts val="800"/>
               </a:spcAft>
+              <a:buFont typeface="Arial"/>
+              <a:buChar char="•"/>
             </a:pPr>
             <a:r>
               <a:rPr sz="1800" b="0">
@@ -6430,10 +6526,12 @@
             </a:r>
           </a:p>
           <a:p>
-            <a:pPr>
+            <a:pPr marL="256032" indent="-164592">
               <a:spcAft>
                 <a:spcPts val="800"/>
               </a:spcAft>
+              <a:buFont typeface="Arial"/>
+              <a:buChar char="•"/>
             </a:pPr>
             <a:r>
               <a:rPr sz="1800" b="0">
@@ -6640,7 +6738,7 @@
                 </a:solidFill>
                 <a:latin typeface="Arial"/>
               </a:rPr>
-              <a:t>Why fuse: complementary heads, not one network</a:t>
+              <a:t>Why fuse: complementary heads, not one bigger net</a:t>
             </a:r>
           </a:p>
         </p:txBody>
@@ -6661,24 +6759,48 @@
         </p:blipFill>
         <p:spPr>
           <a:xfrm>
-            <a:off x="365760" y="1005840"/>
-            <a:ext cx="11430000" cy="4114800"/>
+            <a:off x="365760" y="868680"/>
+            <a:ext cx="11430000" cy="2468880"/>
           </a:xfrm>
           <a:prstGeom prst="rect">
             <a:avLst/>
           </a:prstGeom>
         </p:spPr>
       </p:pic>
-      <p:sp>
-        <p:nvSpPr>
-          <p:cNvPr id="4" name="TextBox 3"/>
+      <p:pic>
+        <p:nvPicPr>
+          <p:cNvPr id="4" name="Picture 3" descr="fuse_why.png"/>
+          <p:cNvPicPr>
+            <a:picLocks noChangeAspect="1"/>
+          </p:cNvPicPr>
+          <p:nvPr/>
+        </p:nvPicPr>
+        <p:blipFill>
+          <a:blip r:embed="rId3"/>
+          <a:stretch>
+            <a:fillRect/>
+          </a:stretch>
+        </p:blipFill>
+        <p:spPr>
+          <a:xfrm>
+            <a:off x="365760" y="3429000"/>
+            <a:ext cx="11430000" cy="1965960"/>
+          </a:xfrm>
+          <a:prstGeom prst="rect">
+            <a:avLst/>
+          </a:prstGeom>
+        </p:spPr>
+      </p:pic>
+      <p:sp>
+        <p:nvSpPr>
+          <p:cNvPr id="5" name="TextBox 4"/>
           <p:cNvSpPr txBox="1"/>
           <p:nvPr/>
         </p:nvSpPr>
         <p:spPr>
           <a:xfrm>
-            <a:off x="457200" y="5212080"/>
-            <a:ext cx="11247120" cy="1280160"/>
+            <a:off x="457200" y="5532120"/>
+            <a:ext cx="11247120" cy="1005840"/>
           </a:xfrm>
           <a:prstGeom prst="rect">
             <a:avLst/>
@@ -6691,42 +6813,46 @@
           </a:bodyPr>
           <a:lstStyle/>
           <a:p>
-            <a:pPr>
+            <a:pPr marL="256032" indent="-164592">
               <a:spcAft>
                 <a:spcPts val="800"/>
               </a:spcAft>
+              <a:buFont typeface="Arial"/>
+              <a:buChar char="•"/>
             </a:pPr>
             <a:r>
-              <a:rPr sz="1600" b="0">
+              <a:rPr sz="1400" b="0">
                 <a:solidFill>
                   <a:srgbClr val="0F172A"/>
                 </a:solidFill>
                 <a:latin typeface="Arial"/>
               </a:rPr>
-              <a:t>last-4: best DALL·E ranking, conservative at 0.5 (1 FP / 60 FN). Nova rec 0.49.</a:t>
-            </a:r>
-          </a:p>
-          <a:p>
-            <a:pPr>
+              <a:t>last-4 ranks DALL·E (0.990) but misses Nova at 0.5 (rec 0.49). D3 is the opposite: Nova rec 0.86, official only 0.978.</a:t>
+            </a:r>
+          </a:p>
+          <a:p>
+            <a:pPr marL="256032" indent="-164592">
               <a:spcAft>
                 <a:spcPts val="800"/>
               </a:spcAft>
+              <a:buFont typeface="Arial"/>
+              <a:buChar char="•"/>
             </a:pPr>
             <a:r>
-              <a:rPr sz="1600" b="0">
+              <a:rPr sz="1400" b="0">
                 <a:solidFill>
                   <a:srgbClr val="0F172A"/>
                 </a:solidFill>
                 <a:latin typeface="Arial"/>
               </a:rPr>
-              <a:t>D3: Nova rec 0.86, official only 0.978. Train last-4 on D3 → 0.976. Average logits → 0.993.</a:t>
-            </a:r>
-          </a:p>
-        </p:txBody>
-      </p:sp>
-      <p:sp>
-        <p:nvSpPr>
-          <p:cNvPr id="5" name="TextBox 4"/>
+              <a:t>Average logits at inference → 0.993. Training last-4 on the mix drops official to 0.976. D5/D6 fuse 0.9927 / 0.9929 do not beat D3.</a:t>
+            </a:r>
+          </a:p>
+        </p:txBody>
+      </p:sp>
+      <p:sp>
+        <p:nvSpPr>
+          <p:cNvPr id="6" name="TextBox 5"/>
           <p:cNvSpPr txBox="1"/>
           <p:nvPr/>
         </p:nvSpPr>

</xml_diff>